<commit_message>
Final Emergency Fix: Liberal modification logic for buyer orders
</commit_message>
<xml_diff>
--- a/1-Final/新增 Microsoft PowerPoint 簡報 (5) [自動儲存].pptx
+++ b/1-Final/新增 Microsoft PowerPoint 簡報 (5) [自動儲存].pptx
@@ -16,6 +16,7 @@
     <p:sldId id="263" r:id="rId10"/>
     <p:sldId id="264" r:id="rId11"/>
     <p:sldId id="265" r:id="rId12"/>
+    <p:sldId id="270" r:id="rId13"/>
   </p:sldIdLst>
   <p:sldSz cx="6858000" cy="9144000" type="screen4x3"/>
   <p:notesSz cx="6858000" cy="9144000"/>
@@ -312,7 +313,7 @@
           <a:p>
             <a:fld id="{5BBEAD13-0566-4C6C-97E7-55F17F24B09F}" type="datetimeFigureOut">
               <a:rPr lang="zh-TW" altLang="en-US" smtClean="0"/>
-              <a:t>2026/2/24</a:t>
+              <a:t>2026/3/10</a:t>
             </a:fld>
             <a:endParaRPr lang="zh-TW" altLang="en-US"/>
           </a:p>
@@ -475,7 +476,7 @@
           <a:p>
             <a:fld id="{5BBEAD13-0566-4C6C-97E7-55F17F24B09F}" type="datetimeFigureOut">
               <a:rPr lang="zh-TW" altLang="en-US" smtClean="0"/>
-              <a:t>2026/2/24</a:t>
+              <a:t>2026/3/10</a:t>
             </a:fld>
             <a:endParaRPr lang="zh-TW" altLang="en-US"/>
           </a:p>
@@ -648,7 +649,7 @@
           <a:p>
             <a:fld id="{5BBEAD13-0566-4C6C-97E7-55F17F24B09F}" type="datetimeFigureOut">
               <a:rPr lang="zh-TW" altLang="en-US" smtClean="0"/>
-              <a:t>2026/2/24</a:t>
+              <a:t>2026/3/10</a:t>
             </a:fld>
             <a:endParaRPr lang="zh-TW" altLang="en-US"/>
           </a:p>
@@ -811,7 +812,7 @@
           <a:p>
             <a:fld id="{5BBEAD13-0566-4C6C-97E7-55F17F24B09F}" type="datetimeFigureOut">
               <a:rPr lang="zh-TW" altLang="en-US" smtClean="0"/>
-              <a:t>2026/2/24</a:t>
+              <a:t>2026/3/10</a:t>
             </a:fld>
             <a:endParaRPr lang="zh-TW" altLang="en-US"/>
           </a:p>
@@ -1051,7 +1052,7 @@
           <a:p>
             <a:fld id="{5BBEAD13-0566-4C6C-97E7-55F17F24B09F}" type="datetimeFigureOut">
               <a:rPr lang="zh-TW" altLang="en-US" smtClean="0"/>
-              <a:t>2026/2/24</a:t>
+              <a:t>2026/3/10</a:t>
             </a:fld>
             <a:endParaRPr lang="zh-TW" altLang="en-US"/>
           </a:p>
@@ -1331,7 +1332,7 @@
           <a:p>
             <a:fld id="{5BBEAD13-0566-4C6C-97E7-55F17F24B09F}" type="datetimeFigureOut">
               <a:rPr lang="zh-TW" altLang="en-US" smtClean="0"/>
-              <a:t>2026/2/24</a:t>
+              <a:t>2026/3/10</a:t>
             </a:fld>
             <a:endParaRPr lang="zh-TW" altLang="en-US"/>
           </a:p>
@@ -1745,7 +1746,7 @@
           <a:p>
             <a:fld id="{5BBEAD13-0566-4C6C-97E7-55F17F24B09F}" type="datetimeFigureOut">
               <a:rPr lang="zh-TW" altLang="en-US" smtClean="0"/>
-              <a:t>2026/2/24</a:t>
+              <a:t>2026/3/10</a:t>
             </a:fld>
             <a:endParaRPr lang="zh-TW" altLang="en-US"/>
           </a:p>
@@ -1857,7 +1858,7 @@
           <a:p>
             <a:fld id="{5BBEAD13-0566-4C6C-97E7-55F17F24B09F}" type="datetimeFigureOut">
               <a:rPr lang="zh-TW" altLang="en-US" smtClean="0"/>
-              <a:t>2026/2/24</a:t>
+              <a:t>2026/3/10</a:t>
             </a:fld>
             <a:endParaRPr lang="zh-TW" altLang="en-US"/>
           </a:p>
@@ -1947,7 +1948,7 @@
           <a:p>
             <a:fld id="{5BBEAD13-0566-4C6C-97E7-55F17F24B09F}" type="datetimeFigureOut">
               <a:rPr lang="zh-TW" altLang="en-US" smtClean="0"/>
-              <a:t>2026/2/24</a:t>
+              <a:t>2026/3/10</a:t>
             </a:fld>
             <a:endParaRPr lang="zh-TW" altLang="en-US"/>
           </a:p>
@@ -2217,7 +2218,7 @@
           <a:p>
             <a:fld id="{5BBEAD13-0566-4C6C-97E7-55F17F24B09F}" type="datetimeFigureOut">
               <a:rPr lang="zh-TW" altLang="en-US" smtClean="0"/>
-              <a:t>2026/2/24</a:t>
+              <a:t>2026/3/10</a:t>
             </a:fld>
             <a:endParaRPr lang="zh-TW" altLang="en-US"/>
           </a:p>
@@ -2464,7 +2465,7 @@
           <a:p>
             <a:fld id="{5BBEAD13-0566-4C6C-97E7-55F17F24B09F}" type="datetimeFigureOut">
               <a:rPr lang="zh-TW" altLang="en-US" smtClean="0"/>
-              <a:t>2026/2/24</a:t>
+              <a:t>2026/3/10</a:t>
             </a:fld>
             <a:endParaRPr lang="zh-TW" altLang="en-US"/>
           </a:p>
@@ -2670,7 +2671,7 @@
           <a:p>
             <a:fld id="{5BBEAD13-0566-4C6C-97E7-55F17F24B09F}" type="datetimeFigureOut">
               <a:rPr lang="zh-TW" altLang="en-US" smtClean="0"/>
-              <a:t>2026/2/24</a:t>
+              <a:t>2026/3/10</a:t>
             </a:fld>
             <a:endParaRPr lang="zh-TW" altLang="en-US"/>
           </a:p>
@@ -3045,7 +3046,7 @@
           <p:cNvPr id="4" name="文字方塊 3">
             <a:extLst>
               <a:ext uri="{FF2B5EF4-FFF2-40B4-BE49-F238E27FC236}">
-                <a16:creationId xmlns:a16="http://schemas.microsoft.com/office/drawing/2014/main" id="{7FCD40F2-9077-1A99-8F71-7B84A1B2A76A}"/>
+                <a16:creationId xmlns:a16="http://schemas.microsoft.com/office/drawing/2014/main" xmlns="" id="{7FCD40F2-9077-1A99-8F71-7B84A1B2A76A}"/>
               </a:ext>
             </a:extLst>
           </p:cNvPr>
@@ -5952,6 +5953,379 @@
 </p:sld>
 </file>
 
+<file path=ppt/slides/slide12.xml><?xml version="1.0" encoding="utf-8"?>
+<p:sld xmlns:a="http://schemas.openxmlformats.org/drawingml/2006/main" xmlns:r="http://schemas.openxmlformats.org/officeDocument/2006/relationships" xmlns:p="http://schemas.openxmlformats.org/presentationml/2006/main">
+  <p:cSld>
+    <p:spTree>
+      <p:nvGrpSpPr>
+        <p:cNvPr id="1" name=""/>
+        <p:cNvGrpSpPr/>
+        <p:nvPr/>
+      </p:nvGrpSpPr>
+      <p:grpSpPr>
+        <a:xfrm>
+          <a:off x="0" y="0"/>
+          <a:ext cx="0" cy="0"/>
+          <a:chOff x="0" y="0"/>
+          <a:chExt cx="0" cy="0"/>
+        </a:xfrm>
+      </p:grpSpPr>
+      <p:pic>
+        <p:nvPicPr>
+          <p:cNvPr id="5" name="圖片 4"/>
+          <p:cNvPicPr>
+            <a:picLocks noChangeAspect="1"/>
+          </p:cNvPicPr>
+          <p:nvPr/>
+        </p:nvPicPr>
+        <p:blipFill>
+          <a:blip r:embed="rId2" cstate="print">
+            <a:extLst>
+              <a:ext uri="{28A0092B-C50C-407E-A947-70E740481C1C}">
+                <a14:useLocalDpi xmlns:a14="http://schemas.microsoft.com/office/drawing/2010/main" val="0"/>
+              </a:ext>
+            </a:extLst>
+          </a:blip>
+          <a:stretch>
+            <a:fillRect/>
+          </a:stretch>
+        </p:blipFill>
+        <p:spPr>
+          <a:xfrm>
+            <a:off x="77585" y="3548150"/>
+            <a:ext cx="1623223" cy="3126729"/>
+          </a:xfrm>
+          <a:prstGeom prst="rect">
+            <a:avLst/>
+          </a:prstGeom>
+        </p:spPr>
+      </p:pic>
+      <p:pic>
+        <p:nvPicPr>
+          <p:cNvPr id="10" name="圖片 9"/>
+          <p:cNvPicPr>
+            <a:picLocks noChangeAspect="1"/>
+          </p:cNvPicPr>
+          <p:nvPr/>
+        </p:nvPicPr>
+        <p:blipFill>
+          <a:blip r:embed="rId3">
+            <a:extLst>
+              <a:ext uri="{28A0092B-C50C-407E-A947-70E740481C1C}">
+                <a14:useLocalDpi xmlns:a14="http://schemas.microsoft.com/office/drawing/2010/main" val="0"/>
+              </a:ext>
+            </a:extLst>
+          </a:blip>
+          <a:stretch>
+            <a:fillRect/>
+          </a:stretch>
+        </p:blipFill>
+        <p:spPr>
+          <a:xfrm>
+            <a:off x="0" y="26863"/>
+            <a:ext cx="6858000" cy="1655956"/>
+          </a:xfrm>
+          <a:prstGeom prst="rect">
+            <a:avLst/>
+          </a:prstGeom>
+        </p:spPr>
+      </p:pic>
+      <p:sp>
+        <p:nvSpPr>
+          <p:cNvPr id="11" name="矩形 10"/>
+          <p:cNvSpPr/>
+          <p:nvPr/>
+        </p:nvSpPr>
+        <p:spPr>
+          <a:xfrm>
+            <a:off x="692696" y="5580112"/>
+            <a:ext cx="1008112" cy="194758"/>
+          </a:xfrm>
+          <a:prstGeom prst="rect">
+            <a:avLst/>
+          </a:prstGeom>
+          <a:noFill/>
+          <a:ln>
+            <a:solidFill>
+              <a:srgbClr val="FF0000"/>
+            </a:solidFill>
+          </a:ln>
+        </p:spPr>
+        <p:style>
+          <a:lnRef idx="2">
+            <a:schemeClr val="accent1">
+              <a:shade val="50000"/>
+            </a:schemeClr>
+          </a:lnRef>
+          <a:fillRef idx="1">
+            <a:schemeClr val="accent1"/>
+          </a:fillRef>
+          <a:effectRef idx="0">
+            <a:schemeClr val="accent1"/>
+          </a:effectRef>
+          <a:fontRef idx="minor">
+            <a:schemeClr val="lt1"/>
+          </a:fontRef>
+        </p:style>
+        <p:txBody>
+          <a:bodyPr rtlCol="0" anchor="ctr"/>
+          <a:lstStyle/>
+          <a:p>
+            <a:pPr algn="ctr"/>
+            <a:endParaRPr lang="zh-TW" altLang="en-US"/>
+          </a:p>
+        </p:txBody>
+      </p:sp>
+      <p:cxnSp>
+        <p:nvCxnSpPr>
+          <p:cNvPr id="13" name="直線單箭頭接點 12"/>
+          <p:cNvCxnSpPr>
+            <a:endCxn id="11" idx="3"/>
+          </p:cNvCxnSpPr>
+          <p:nvPr/>
+        </p:nvCxnSpPr>
+        <p:spPr>
+          <a:xfrm flipH="1" flipV="1">
+            <a:off x="1700808" y="5677491"/>
+            <a:ext cx="576064" cy="25371"/>
+          </a:xfrm>
+          <a:prstGeom prst="straightConnector1">
+            <a:avLst/>
+          </a:prstGeom>
+          <a:ln>
+            <a:solidFill>
+              <a:srgbClr val="FF0000"/>
+            </a:solidFill>
+            <a:tailEnd type="triangle"/>
+          </a:ln>
+        </p:spPr>
+        <p:style>
+          <a:lnRef idx="1">
+            <a:schemeClr val="accent1"/>
+          </a:lnRef>
+          <a:fillRef idx="0">
+            <a:schemeClr val="accent1"/>
+          </a:fillRef>
+          <a:effectRef idx="0">
+            <a:schemeClr val="accent1"/>
+          </a:effectRef>
+          <a:fontRef idx="minor">
+            <a:schemeClr val="tx1"/>
+          </a:fontRef>
+        </p:style>
+      </p:cxnSp>
+      <p:sp>
+        <p:nvSpPr>
+          <p:cNvPr id="14" name="文字方塊 13"/>
+          <p:cNvSpPr txBox="1"/>
+          <p:nvPr/>
+        </p:nvSpPr>
+        <p:spPr>
+          <a:xfrm>
+            <a:off x="2216422" y="5513260"/>
+            <a:ext cx="2137124" cy="523220"/>
+          </a:xfrm>
+          <a:prstGeom prst="rect">
+            <a:avLst/>
+          </a:prstGeom>
+          <a:noFill/>
+        </p:spPr>
+        <p:txBody>
+          <a:bodyPr wrap="none" rtlCol="0">
+            <a:spAutoFit/>
+          </a:bodyPr>
+          <a:lstStyle/>
+          <a:p>
+            <a:r>
+              <a:rPr lang="en-US" altLang="zh-TW" sz="1400" b="1" dirty="0" smtClean="0">
+                <a:solidFill>
+                  <a:srgbClr val="FF0000"/>
+                </a:solidFill>
+              </a:rPr>
+              <a:t>“</a:t>
+            </a:r>
+            <a:r>
+              <a:rPr lang="zh-TW" altLang="en-US" sz="1400" b="1" dirty="0" smtClean="0">
+                <a:solidFill>
+                  <a:srgbClr val="FF0000"/>
+                </a:solidFill>
+              </a:rPr>
+              <a:t>我要下單</a:t>
+            </a:r>
+            <a:r>
+              <a:rPr lang="en-US" altLang="zh-TW" sz="1400" b="1" dirty="0" smtClean="0">
+                <a:solidFill>
+                  <a:srgbClr val="FF0000"/>
+                </a:solidFill>
+              </a:rPr>
+              <a:t>”</a:t>
+            </a:r>
+            <a:r>
+              <a:rPr lang="zh-TW" altLang="en-US" sz="1400" b="1" dirty="0" smtClean="0">
+                <a:solidFill>
+                  <a:srgbClr val="FF0000"/>
+                </a:solidFill>
+              </a:rPr>
+              <a:t>下單完就出現</a:t>
+            </a:r>
+            <a:endParaRPr lang="en-US" altLang="zh-TW" sz="1400" b="1" dirty="0" smtClean="0">
+              <a:solidFill>
+                <a:srgbClr val="FF0000"/>
+              </a:solidFill>
+            </a:endParaRPr>
+          </a:p>
+          <a:p>
+            <a:r>
+              <a:rPr lang="zh-TW" altLang="en-US" sz="1400" b="1" dirty="0" smtClean="0">
+                <a:solidFill>
+                  <a:srgbClr val="FF0000"/>
+                </a:solidFill>
+              </a:rPr>
+              <a:t>無法修改刪除</a:t>
+            </a:r>
+            <a:endParaRPr lang="zh-TW" altLang="en-US" sz="1400" b="1" dirty="0">
+              <a:solidFill>
+                <a:srgbClr val="FF0000"/>
+              </a:solidFill>
+            </a:endParaRPr>
+          </a:p>
+        </p:txBody>
+      </p:sp>
+      <p:pic>
+        <p:nvPicPr>
+          <p:cNvPr id="20" name="圖片 19"/>
+          <p:cNvPicPr>
+            <a:picLocks noChangeAspect="1"/>
+          </p:cNvPicPr>
+          <p:nvPr/>
+        </p:nvPicPr>
+        <p:blipFill>
+          <a:blip r:embed="rId4">
+            <a:extLst>
+              <a:ext uri="{28A0092B-C50C-407E-A947-70E740481C1C}">
+                <a14:useLocalDpi xmlns:a14="http://schemas.microsoft.com/office/drawing/2010/main" val="0"/>
+              </a:ext>
+            </a:extLst>
+          </a:blip>
+          <a:stretch>
+            <a:fillRect/>
+          </a:stretch>
+        </p:blipFill>
+        <p:spPr>
+          <a:xfrm>
+            <a:off x="7295" y="1750827"/>
+            <a:ext cx="6858000" cy="1729315"/>
+          </a:xfrm>
+          <a:prstGeom prst="rect">
+            <a:avLst/>
+          </a:prstGeom>
+        </p:spPr>
+      </p:pic>
+      <p:sp>
+        <p:nvSpPr>
+          <p:cNvPr id="21" name="矩形 20"/>
+          <p:cNvSpPr/>
+          <p:nvPr/>
+        </p:nvSpPr>
+        <p:spPr>
+          <a:xfrm>
+            <a:off x="-10752" y="1979712"/>
+            <a:ext cx="4807903" cy="144016"/>
+          </a:xfrm>
+          <a:prstGeom prst="rect">
+            <a:avLst/>
+          </a:prstGeom>
+          <a:noFill/>
+          <a:ln>
+            <a:solidFill>
+              <a:srgbClr val="FF0000"/>
+            </a:solidFill>
+          </a:ln>
+        </p:spPr>
+        <p:style>
+          <a:lnRef idx="2">
+            <a:schemeClr val="accent1">
+              <a:shade val="50000"/>
+            </a:schemeClr>
+          </a:lnRef>
+          <a:fillRef idx="1">
+            <a:schemeClr val="accent1"/>
+          </a:fillRef>
+          <a:effectRef idx="0">
+            <a:schemeClr val="accent1"/>
+          </a:effectRef>
+          <a:fontRef idx="minor">
+            <a:schemeClr val="lt1"/>
+          </a:fontRef>
+        </p:style>
+        <p:txBody>
+          <a:bodyPr rtlCol="0" anchor="ctr"/>
+          <a:lstStyle/>
+          <a:p>
+            <a:pPr algn="ctr"/>
+            <a:endParaRPr lang="zh-TW" altLang="en-US"/>
+          </a:p>
+        </p:txBody>
+      </p:sp>
+      <p:sp>
+        <p:nvSpPr>
+          <p:cNvPr id="22" name="矩形 21"/>
+          <p:cNvSpPr/>
+          <p:nvPr/>
+        </p:nvSpPr>
+        <p:spPr>
+          <a:xfrm>
+            <a:off x="77585" y="249233"/>
+            <a:ext cx="6087719" cy="145179"/>
+          </a:xfrm>
+          <a:prstGeom prst="rect">
+            <a:avLst/>
+          </a:prstGeom>
+          <a:noFill/>
+          <a:ln>
+            <a:solidFill>
+              <a:srgbClr val="FF0000"/>
+            </a:solidFill>
+          </a:ln>
+        </p:spPr>
+        <p:style>
+          <a:lnRef idx="2">
+            <a:schemeClr val="accent1">
+              <a:shade val="50000"/>
+            </a:schemeClr>
+          </a:lnRef>
+          <a:fillRef idx="1">
+            <a:schemeClr val="accent1"/>
+          </a:fillRef>
+          <a:effectRef idx="0">
+            <a:schemeClr val="accent1"/>
+          </a:effectRef>
+          <a:fontRef idx="minor">
+            <a:schemeClr val="lt1"/>
+          </a:fontRef>
+        </p:style>
+        <p:txBody>
+          <a:bodyPr rtlCol="0" anchor="ctr"/>
+          <a:lstStyle/>
+          <a:p>
+            <a:pPr algn="ctr"/>
+            <a:endParaRPr lang="zh-TW" altLang="en-US"/>
+          </a:p>
+        </p:txBody>
+      </p:sp>
+    </p:spTree>
+    <p:extLst>
+      <p:ext uri="{BB962C8B-B14F-4D97-AF65-F5344CB8AC3E}">
+        <p14:creationId xmlns:p14="http://schemas.microsoft.com/office/powerpoint/2010/main" val="610132634"/>
+      </p:ext>
+    </p:extLst>
+  </p:cSld>
+  <p:clrMapOvr>
+    <a:masterClrMapping/>
+  </p:clrMapOvr>
+</p:sld>
+</file>
+
 <file path=ppt/slides/slide2.xml><?xml version="1.0" encoding="utf-8"?>
 <p:sld xmlns:a="http://schemas.openxmlformats.org/drawingml/2006/main" xmlns:r="http://schemas.openxmlformats.org/officeDocument/2006/relationships" xmlns:p="http://schemas.openxmlformats.org/presentationml/2006/main">
   <p:cSld>
@@ -6162,7 +6536,7 @@
           <p:cNvPr id="2" name="群組 1">
             <a:extLst>
               <a:ext uri="{FF2B5EF4-FFF2-40B4-BE49-F238E27FC236}">
-                <a16:creationId xmlns:a16="http://schemas.microsoft.com/office/drawing/2014/main" id="{D408DAFA-1B92-7C95-34F5-E72C2D69ABDF}"/>
+                <a16:creationId xmlns:a16="http://schemas.microsoft.com/office/drawing/2014/main" xmlns="" id="{D408DAFA-1B92-7C95-34F5-E72C2D69ABDF}"/>
               </a:ext>
             </a:extLst>
           </p:cNvPr>
@@ -6182,7 +6556,7 @@
             <p:cNvPr id="3" name="圖片 2">
               <a:extLst>
                 <a:ext uri="{FF2B5EF4-FFF2-40B4-BE49-F238E27FC236}">
-                  <a16:creationId xmlns:a16="http://schemas.microsoft.com/office/drawing/2014/main" id="{405B0C76-FC18-B637-B95D-1083B565A7C4}"/>
+                  <a16:creationId xmlns:a16="http://schemas.microsoft.com/office/drawing/2014/main" xmlns="" id="{405B0C76-FC18-B637-B95D-1083B565A7C4}"/>
                 </a:ext>
               </a:extLst>
             </p:cNvPr>
@@ -6218,7 +6592,7 @@
             <p:cNvPr id="10" name="文字方塊 9">
               <a:extLst>
                 <a:ext uri="{FF2B5EF4-FFF2-40B4-BE49-F238E27FC236}">
-                  <a16:creationId xmlns:a16="http://schemas.microsoft.com/office/drawing/2014/main" id="{E58CF7B8-9C81-AFF9-A43A-5459623C8D03}"/>
+                  <a16:creationId xmlns:a16="http://schemas.microsoft.com/office/drawing/2014/main" xmlns="" id="{E58CF7B8-9C81-AFF9-A43A-5459623C8D03}"/>
                 </a:ext>
               </a:extLst>
             </p:cNvPr>
@@ -6283,7 +6657,7 @@
             <p:cNvPr id="11" name="直線單箭頭接點 10">
               <a:extLst>
                 <a:ext uri="{FF2B5EF4-FFF2-40B4-BE49-F238E27FC236}">
-                  <a16:creationId xmlns:a16="http://schemas.microsoft.com/office/drawing/2014/main" id="{6BD5CEC3-2C63-DDDE-CEC7-CF4E5EAA0D4C}"/>
+                  <a16:creationId xmlns:a16="http://schemas.microsoft.com/office/drawing/2014/main" xmlns="" id="{6BD5CEC3-2C63-DDDE-CEC7-CF4E5EAA0D4C}"/>
                 </a:ext>
               </a:extLst>
             </p:cNvPr>
@@ -6325,7 +6699,7 @@
             <p:cNvPr id="15" name="直線單箭頭接點 14">
               <a:extLst>
                 <a:ext uri="{FF2B5EF4-FFF2-40B4-BE49-F238E27FC236}">
-                  <a16:creationId xmlns:a16="http://schemas.microsoft.com/office/drawing/2014/main" id="{33BEF131-D493-C05F-820D-60E25DDAED5E}"/>
+                  <a16:creationId xmlns:a16="http://schemas.microsoft.com/office/drawing/2014/main" xmlns="" id="{33BEF131-D493-C05F-820D-60E25DDAED5E}"/>
                 </a:ext>
               </a:extLst>
             </p:cNvPr>
@@ -6367,7 +6741,7 @@
             <p:cNvPr id="16" name="肘形接點 27">
               <a:extLst>
                 <a:ext uri="{FF2B5EF4-FFF2-40B4-BE49-F238E27FC236}">
-                  <a16:creationId xmlns:a16="http://schemas.microsoft.com/office/drawing/2014/main" id="{5BABC4F3-5962-7131-0584-408D91D6D616}"/>
+                  <a16:creationId xmlns:a16="http://schemas.microsoft.com/office/drawing/2014/main" xmlns="" id="{5BABC4F3-5962-7131-0584-408D91D6D616}"/>
                 </a:ext>
               </a:extLst>
             </p:cNvPr>
@@ -6414,7 +6788,7 @@
             <p:cNvPr id="17" name="直線單箭頭接點 16">
               <a:extLst>
                 <a:ext uri="{FF2B5EF4-FFF2-40B4-BE49-F238E27FC236}">
-                  <a16:creationId xmlns:a16="http://schemas.microsoft.com/office/drawing/2014/main" id="{420755E3-EB5D-0B85-859A-074843772498}"/>
+                  <a16:creationId xmlns:a16="http://schemas.microsoft.com/office/drawing/2014/main" xmlns="" id="{420755E3-EB5D-0B85-859A-074843772498}"/>
                 </a:ext>
               </a:extLst>
             </p:cNvPr>
@@ -6456,7 +6830,7 @@
             <p:cNvPr id="18" name="肘形接點 40">
               <a:extLst>
                 <a:ext uri="{FF2B5EF4-FFF2-40B4-BE49-F238E27FC236}">
-                  <a16:creationId xmlns:a16="http://schemas.microsoft.com/office/drawing/2014/main" id="{32B29F09-79AB-8DBB-1C85-6C90E1E3A5A7}"/>
+                  <a16:creationId xmlns:a16="http://schemas.microsoft.com/office/drawing/2014/main" xmlns="" id="{32B29F09-79AB-8DBB-1C85-6C90E1E3A5A7}"/>
                 </a:ext>
               </a:extLst>
             </p:cNvPr>
@@ -6502,7 +6876,7 @@
             <p:cNvPr id="19" name="直線單箭頭接點 18">
               <a:extLst>
                 <a:ext uri="{FF2B5EF4-FFF2-40B4-BE49-F238E27FC236}">
-                  <a16:creationId xmlns:a16="http://schemas.microsoft.com/office/drawing/2014/main" id="{F1B7BF54-F6C2-4C76-319E-7F06CE98D2EC}"/>
+                  <a16:creationId xmlns:a16="http://schemas.microsoft.com/office/drawing/2014/main" xmlns="" id="{F1B7BF54-F6C2-4C76-319E-7F06CE98D2EC}"/>
                 </a:ext>
               </a:extLst>
             </p:cNvPr>
@@ -6544,7 +6918,7 @@
             <p:cNvPr id="20" name="圖片 19">
               <a:extLst>
                 <a:ext uri="{FF2B5EF4-FFF2-40B4-BE49-F238E27FC236}">
-                  <a16:creationId xmlns:a16="http://schemas.microsoft.com/office/drawing/2014/main" id="{2165DD2C-0794-D907-5410-EB59DCA93881}"/>
+                  <a16:creationId xmlns:a16="http://schemas.microsoft.com/office/drawing/2014/main" xmlns="" id="{2165DD2C-0794-D907-5410-EB59DCA93881}"/>
                 </a:ext>
               </a:extLst>
             </p:cNvPr>
@@ -6580,7 +6954,7 @@
             <p:cNvPr id="21" name="直線單箭頭接點 20">
               <a:extLst>
                 <a:ext uri="{FF2B5EF4-FFF2-40B4-BE49-F238E27FC236}">
-                  <a16:creationId xmlns:a16="http://schemas.microsoft.com/office/drawing/2014/main" id="{30C38612-BB1A-6AEE-4E34-FBAC35B6CE98}"/>
+                  <a16:creationId xmlns:a16="http://schemas.microsoft.com/office/drawing/2014/main" xmlns="" id="{30C38612-BB1A-6AEE-4E34-FBAC35B6CE98}"/>
                 </a:ext>
               </a:extLst>
             </p:cNvPr>
@@ -6622,7 +6996,7 @@
             <p:cNvPr id="22" name="圖片 21">
               <a:extLst>
                 <a:ext uri="{FF2B5EF4-FFF2-40B4-BE49-F238E27FC236}">
-                  <a16:creationId xmlns:a16="http://schemas.microsoft.com/office/drawing/2014/main" id="{FA4C5856-8DB1-0BA4-18C9-3067FD345DBE}"/>
+                  <a16:creationId xmlns:a16="http://schemas.microsoft.com/office/drawing/2014/main" xmlns="" id="{FA4C5856-8DB1-0BA4-18C9-3067FD345DBE}"/>
                 </a:ext>
               </a:extLst>
             </p:cNvPr>
@@ -6658,7 +7032,7 @@
             <p:cNvPr id="23" name="圖片 22">
               <a:extLst>
                 <a:ext uri="{FF2B5EF4-FFF2-40B4-BE49-F238E27FC236}">
-                  <a16:creationId xmlns:a16="http://schemas.microsoft.com/office/drawing/2014/main" id="{EEAD33F3-15F8-3E7A-9833-0EEB66D5A639}"/>
+                  <a16:creationId xmlns:a16="http://schemas.microsoft.com/office/drawing/2014/main" xmlns="" id="{EEAD33F3-15F8-3E7A-9833-0EEB66D5A639}"/>
                 </a:ext>
               </a:extLst>
             </p:cNvPr>
@@ -6688,7 +7062,7 @@
             <p:cNvPr id="24" name="直線單箭頭接點 23">
               <a:extLst>
                 <a:ext uri="{FF2B5EF4-FFF2-40B4-BE49-F238E27FC236}">
-                  <a16:creationId xmlns:a16="http://schemas.microsoft.com/office/drawing/2014/main" id="{5CC55BE7-28FC-13C8-2E50-27EC44C26040}"/>
+                  <a16:creationId xmlns:a16="http://schemas.microsoft.com/office/drawing/2014/main" xmlns="" id="{5CC55BE7-28FC-13C8-2E50-27EC44C26040}"/>
                 </a:ext>
               </a:extLst>
             </p:cNvPr>
@@ -6732,7 +7106,7 @@
             <p:cNvPr id="25" name="圖片 24">
               <a:extLst>
                 <a:ext uri="{FF2B5EF4-FFF2-40B4-BE49-F238E27FC236}">
-                  <a16:creationId xmlns:a16="http://schemas.microsoft.com/office/drawing/2014/main" id="{3FA6DAE3-22A6-B07C-858B-9566F1D5950A}"/>
+                  <a16:creationId xmlns:a16="http://schemas.microsoft.com/office/drawing/2014/main" xmlns="" id="{3FA6DAE3-22A6-B07C-858B-9566F1D5950A}"/>
                 </a:ext>
               </a:extLst>
             </p:cNvPr>
@@ -6768,7 +7142,7 @@
             <p:cNvPr id="26" name="圖片 25">
               <a:extLst>
                 <a:ext uri="{FF2B5EF4-FFF2-40B4-BE49-F238E27FC236}">
-                  <a16:creationId xmlns:a16="http://schemas.microsoft.com/office/drawing/2014/main" id="{0955305B-C51F-E833-B0D5-F28CE57FBA88}"/>
+                  <a16:creationId xmlns:a16="http://schemas.microsoft.com/office/drawing/2014/main" xmlns="" id="{0955305B-C51F-E833-B0D5-F28CE57FBA88}"/>
                 </a:ext>
               </a:extLst>
             </p:cNvPr>
@@ -6804,7 +7178,7 @@
             <p:cNvPr id="27" name="圖片 26">
               <a:extLst>
                 <a:ext uri="{FF2B5EF4-FFF2-40B4-BE49-F238E27FC236}">
-                  <a16:creationId xmlns:a16="http://schemas.microsoft.com/office/drawing/2014/main" id="{E42FFE4B-C8FC-4FD6-26D2-CDE3B12751A2}"/>
+                  <a16:creationId xmlns:a16="http://schemas.microsoft.com/office/drawing/2014/main" xmlns="" id="{E42FFE4B-C8FC-4FD6-26D2-CDE3B12751A2}"/>
                 </a:ext>
               </a:extLst>
             </p:cNvPr>
@@ -6840,7 +7214,7 @@
             <p:cNvPr id="28" name="圖片 27">
               <a:extLst>
                 <a:ext uri="{FF2B5EF4-FFF2-40B4-BE49-F238E27FC236}">
-                  <a16:creationId xmlns:a16="http://schemas.microsoft.com/office/drawing/2014/main" id="{57C34D73-539C-6703-FDA8-04B6C2A39308}"/>
+                  <a16:creationId xmlns:a16="http://schemas.microsoft.com/office/drawing/2014/main" xmlns="" id="{57C34D73-539C-6703-FDA8-04B6C2A39308}"/>
                 </a:ext>
               </a:extLst>
             </p:cNvPr>

</xml_diff>

<commit_message>
Fix: Show close date in mall, strict spec validation, and fix admin list loading
</commit_message>
<xml_diff>
--- a/1-Final/新增 Microsoft PowerPoint 簡報 (5) [自動儲存].pptx
+++ b/1-Final/新增 Microsoft PowerPoint 簡報 (5) [自動儲存].pptx
@@ -307,7 +307,7 @@
           <a:p>
             <a:fld id="{5BBEAD13-0566-4C6C-97E7-55F17F24B09F}" type="datetimeFigureOut">
               <a:rPr lang="zh-TW" altLang="en-US" smtClean="0"/>
-              <a:t>2026/3/11</a:t>
+              <a:t>2026/3/21</a:t>
             </a:fld>
             <a:endParaRPr lang="zh-TW" altLang="en-US"/>
           </a:p>
@@ -470,7 +470,7 @@
           <a:p>
             <a:fld id="{5BBEAD13-0566-4C6C-97E7-55F17F24B09F}" type="datetimeFigureOut">
               <a:rPr lang="zh-TW" altLang="en-US" smtClean="0"/>
-              <a:t>2026/3/11</a:t>
+              <a:t>2026/3/21</a:t>
             </a:fld>
             <a:endParaRPr lang="zh-TW" altLang="en-US"/>
           </a:p>
@@ -643,7 +643,7 @@
           <a:p>
             <a:fld id="{5BBEAD13-0566-4C6C-97E7-55F17F24B09F}" type="datetimeFigureOut">
               <a:rPr lang="zh-TW" altLang="en-US" smtClean="0"/>
-              <a:t>2026/3/11</a:t>
+              <a:t>2026/3/21</a:t>
             </a:fld>
             <a:endParaRPr lang="zh-TW" altLang="en-US"/>
           </a:p>
@@ -806,7 +806,7 @@
           <a:p>
             <a:fld id="{5BBEAD13-0566-4C6C-97E7-55F17F24B09F}" type="datetimeFigureOut">
               <a:rPr lang="zh-TW" altLang="en-US" smtClean="0"/>
-              <a:t>2026/3/11</a:t>
+              <a:t>2026/3/21</a:t>
             </a:fld>
             <a:endParaRPr lang="zh-TW" altLang="en-US"/>
           </a:p>
@@ -1046,7 +1046,7 @@
           <a:p>
             <a:fld id="{5BBEAD13-0566-4C6C-97E7-55F17F24B09F}" type="datetimeFigureOut">
               <a:rPr lang="zh-TW" altLang="en-US" smtClean="0"/>
-              <a:t>2026/3/11</a:t>
+              <a:t>2026/3/21</a:t>
             </a:fld>
             <a:endParaRPr lang="zh-TW" altLang="en-US"/>
           </a:p>
@@ -1326,7 +1326,7 @@
           <a:p>
             <a:fld id="{5BBEAD13-0566-4C6C-97E7-55F17F24B09F}" type="datetimeFigureOut">
               <a:rPr lang="zh-TW" altLang="en-US" smtClean="0"/>
-              <a:t>2026/3/11</a:t>
+              <a:t>2026/3/21</a:t>
             </a:fld>
             <a:endParaRPr lang="zh-TW" altLang="en-US"/>
           </a:p>
@@ -1740,7 +1740,7 @@
           <a:p>
             <a:fld id="{5BBEAD13-0566-4C6C-97E7-55F17F24B09F}" type="datetimeFigureOut">
               <a:rPr lang="zh-TW" altLang="en-US" smtClean="0"/>
-              <a:t>2026/3/11</a:t>
+              <a:t>2026/3/21</a:t>
             </a:fld>
             <a:endParaRPr lang="zh-TW" altLang="en-US"/>
           </a:p>
@@ -1852,7 +1852,7 @@
           <a:p>
             <a:fld id="{5BBEAD13-0566-4C6C-97E7-55F17F24B09F}" type="datetimeFigureOut">
               <a:rPr lang="zh-TW" altLang="en-US" smtClean="0"/>
-              <a:t>2026/3/11</a:t>
+              <a:t>2026/3/21</a:t>
             </a:fld>
             <a:endParaRPr lang="zh-TW" altLang="en-US"/>
           </a:p>
@@ -1942,7 +1942,7 @@
           <a:p>
             <a:fld id="{5BBEAD13-0566-4C6C-97E7-55F17F24B09F}" type="datetimeFigureOut">
               <a:rPr lang="zh-TW" altLang="en-US" smtClean="0"/>
-              <a:t>2026/3/11</a:t>
+              <a:t>2026/3/21</a:t>
             </a:fld>
             <a:endParaRPr lang="zh-TW" altLang="en-US"/>
           </a:p>
@@ -2212,7 +2212,7 @@
           <a:p>
             <a:fld id="{5BBEAD13-0566-4C6C-97E7-55F17F24B09F}" type="datetimeFigureOut">
               <a:rPr lang="zh-TW" altLang="en-US" smtClean="0"/>
-              <a:t>2026/3/11</a:t>
+              <a:t>2026/3/21</a:t>
             </a:fld>
             <a:endParaRPr lang="zh-TW" altLang="en-US"/>
           </a:p>
@@ -2459,7 +2459,7 @@
           <a:p>
             <a:fld id="{5BBEAD13-0566-4C6C-97E7-55F17F24B09F}" type="datetimeFigureOut">
               <a:rPr lang="zh-TW" altLang="en-US" smtClean="0"/>
-              <a:t>2026/3/11</a:t>
+              <a:t>2026/3/21</a:t>
             </a:fld>
             <a:endParaRPr lang="zh-TW" altLang="en-US"/>
           </a:p>
@@ -2665,7 +2665,7 @@
           <a:p>
             <a:fld id="{5BBEAD13-0566-4C6C-97E7-55F17F24B09F}" type="datetimeFigureOut">
               <a:rPr lang="zh-TW" altLang="en-US" smtClean="0"/>
-              <a:t>2026/3/11</a:t>
+              <a:t>2026/3/21</a:t>
             </a:fld>
             <a:endParaRPr lang="zh-TW" altLang="en-US"/>
           </a:p>
@@ -3040,7 +3040,7 @@
           <p:cNvPr id="4" name="文字方塊 3">
             <a:extLst>
               <a:ext uri="{FF2B5EF4-FFF2-40B4-BE49-F238E27FC236}">
-                <a16:creationId xmlns="" xmlns:a16="http://schemas.microsoft.com/office/drawing/2014/main" id="{7FCD40F2-9077-1A99-8F71-7B84A1B2A76A}"/>
+                <a16:creationId xmlns:a16="http://schemas.microsoft.com/office/drawing/2014/main" xmlns="" id="{7FCD40F2-9077-1A99-8F71-7B84A1B2A76A}"/>
               </a:ext>
             </a:extLst>
           </p:cNvPr>
@@ -4438,28 +4438,22 @@
       </p:grpSpPr>
       <p:pic>
         <p:nvPicPr>
-          <p:cNvPr id="3" name="圖片 2"/>
+          <p:cNvPr id="2" name="圖片 1"/>
           <p:cNvPicPr>
             <a:picLocks noChangeAspect="1"/>
           </p:cNvPicPr>
           <p:nvPr/>
         </p:nvPicPr>
         <p:blipFill>
-          <a:blip r:embed="rId2">
-            <a:extLst>
-              <a:ext uri="{28A0092B-C50C-407E-A947-70E740481C1C}">
-                <a14:useLocalDpi xmlns:a14="http://schemas.microsoft.com/office/drawing/2010/main" val="0"/>
-              </a:ext>
-            </a:extLst>
-          </a:blip>
+          <a:blip r:embed="rId2"/>
           <a:stretch>
             <a:fillRect/>
           </a:stretch>
         </p:blipFill>
         <p:spPr>
           <a:xfrm>
-            <a:off x="260648" y="3564"/>
-            <a:ext cx="6192688" cy="9142251"/>
+            <a:off x="357722" y="83823"/>
+            <a:ext cx="6483138" cy="8919204"/>
           </a:xfrm>
           <a:prstGeom prst="rect">
             <a:avLst/>

</xml_diff>